<commit_message>
Add MiniMax H3 data layout flow slide
</commit_message>
<xml_diff>
--- a/scripts/minimax_h3_ulysses_u4_slides/MiniMax-H3_Ulysses_U4_学术解析.pptx
+++ b/scripts/minimax_h3_ulysses_u4_slides/MiniMax-H3_Ulysses_U4_学术解析.pptx
@@ -11,6 +11,7 @@
     <p:sldId id="259" r:id="rId10"/>
     <p:sldId id="260" r:id="rId11"/>
     <p:sldId id="261" r:id="rId12"/>
+    <p:sldId id="262" r:id="rId13"/>
   </p:sldIdLst>
   <p:sldSz cx="12191695" cy="6858000" type="screen4x3"/>
   <p:notesSz cx="6858000" cy="9144000"/>
@@ -3168,8 +3169,8 @@
         </p:nvSpPr>
         <p:spPr>
           <a:xfrm>
-            <a:off x="1097280" y="1353312"/>
-            <a:ext cx="502920" cy="411480"/>
+            <a:off x="1097280" y="1225296"/>
+            <a:ext cx="502920" cy="384048"/>
           </a:xfrm>
           <a:prstGeom prst="rect">
             <a:avLst/>
@@ -3194,7 +3195,7 @@
               </a:spcAft>
             </a:pPr>
             <a:r>
-              <a:rPr sz="2100" b="1">
+              <a:rPr sz="1900" b="1">
                 <a:solidFill>
                   <a:srgbClr val="548235"/>
                 </a:solidFill>
@@ -3213,8 +3214,8 @@
         </p:nvSpPr>
         <p:spPr>
           <a:xfrm>
-            <a:off x="1783080" y="1353312"/>
-            <a:ext cx="9052560" cy="411480"/>
+            <a:off x="1783080" y="1225296"/>
+            <a:ext cx="9052560" cy="384048"/>
           </a:xfrm>
           <a:prstGeom prst="rect">
             <a:avLst/>
@@ -3239,7 +3240,7 @@
               </a:spcAft>
             </a:pPr>
             <a:r>
-              <a:rPr sz="2100" b="0">
+              <a:rPr sz="1900" b="0">
                 <a:solidFill>
                   <a:srgbClr val="1F1F1F"/>
                 </a:solidFill>
@@ -3258,7 +3259,7 @@
         </p:nvCxnSpPr>
         <p:spPr>
           <a:xfrm>
-            <a:off x="1097280" y="1883664"/>
+            <a:off x="1097280" y="1700784"/>
             <a:ext cx="9875520" cy="0"/>
           </a:xfrm>
           <a:prstGeom prst="line">
@@ -3293,8 +3294,8 @@
         </p:nvSpPr>
         <p:spPr>
           <a:xfrm>
-            <a:off x="1097280" y="2221991"/>
-            <a:ext cx="502920" cy="411480"/>
+            <a:off x="1097280" y="1993392"/>
+            <a:ext cx="502920" cy="384048"/>
           </a:xfrm>
           <a:prstGeom prst="rect">
             <a:avLst/>
@@ -3319,7 +3320,7 @@
               </a:spcAft>
             </a:pPr>
             <a:r>
-              <a:rPr sz="2100" b="1">
+              <a:rPr sz="1900" b="1">
                 <a:solidFill>
                   <a:srgbClr val="548235"/>
                 </a:solidFill>
@@ -3338,8 +3339,8 @@
         </p:nvSpPr>
         <p:spPr>
           <a:xfrm>
-            <a:off x="1783080" y="2221991"/>
-            <a:ext cx="9052560" cy="411480"/>
+            <a:off x="1783080" y="1993392"/>
+            <a:ext cx="9052560" cy="384048"/>
           </a:xfrm>
           <a:prstGeom prst="rect">
             <a:avLst/>
@@ -3364,7 +3365,132 @@
               </a:spcAft>
             </a:pPr>
             <a:r>
-              <a:rPr sz="2100" b="0">
+              <a:rPr sz="1900" b="0">
+                <a:solidFill>
+                  <a:srgbClr val="1F1F1F"/>
+                </a:solidFill>
+                <a:latin typeface="Aptos"/>
+              </a:rPr>
+              <a:t>Original Data Layout Flow</a:t>
+            </a:r>
+          </a:p>
+        </p:txBody>
+      </p:sp>
+      <p:cxnSp>
+        <p:nvCxnSpPr>
+          <p:cNvPr id="9" name="Connector 8"/>
+          <p:cNvCxnSpPr/>
+          <p:nvPr/>
+        </p:nvCxnSpPr>
+        <p:spPr>
+          <a:xfrm>
+            <a:off x="1097280" y="2468880"/>
+            <a:ext cx="9875520" cy="0"/>
+          </a:xfrm>
+          <a:prstGeom prst="line">
+            <a:avLst/>
+          </a:prstGeom>
+          <a:ln w="7620">
+            <a:solidFill>
+              <a:srgbClr val="D9D9D9"/>
+            </a:solidFill>
+          </a:ln>
+        </p:spPr>
+        <p:style>
+          <a:lnRef idx="2">
+            <a:schemeClr val="accent1"/>
+          </a:lnRef>
+          <a:fillRef idx="0">
+            <a:schemeClr val="accent1"/>
+          </a:fillRef>
+          <a:effectRef idx="1">
+            <a:schemeClr val="accent1"/>
+          </a:effectRef>
+          <a:fontRef idx="minor">
+            <a:schemeClr val="tx1"/>
+          </a:fontRef>
+        </p:style>
+      </p:cxnSp>
+      <p:sp>
+        <p:nvSpPr>
+          <p:cNvPr id="10" name="TextBox 9"/>
+          <p:cNvSpPr txBox="1"/>
+          <p:nvPr/>
+        </p:nvSpPr>
+        <p:spPr>
+          <a:xfrm>
+            <a:off x="1097280" y="2761488"/>
+            <a:ext cx="502920" cy="384048"/>
+          </a:xfrm>
+          <a:prstGeom prst="rect">
+            <a:avLst/>
+          </a:prstGeom>
+          <a:noFill/>
+        </p:spPr>
+        <p:txBody>
+          <a:bodyPr wrap="square" lIns="36576" rIns="36576" tIns="18288" bIns="18288" anchor="t">
+            <a:spAutoFit/>
+          </a:bodyPr>
+          <a:lstStyle/>
+          <a:p>
+            <a:pPr algn="l">
+              <a:lnSpc>
+                <a:spcPct val="100000"/>
+              </a:lnSpc>
+              <a:spcBef>
+                <a:spcPts val="0"/>
+              </a:spcBef>
+              <a:spcAft>
+                <a:spcPts val="0"/>
+              </a:spcAft>
+            </a:pPr>
+            <a:r>
+              <a:rPr sz="1900" b="1">
+                <a:solidFill>
+                  <a:srgbClr val="548235"/>
+                </a:solidFill>
+                <a:latin typeface="Consolas"/>
+              </a:rPr>
+              <a:t>4</a:t>
+            </a:r>
+          </a:p>
+        </p:txBody>
+      </p:sp>
+      <p:sp>
+        <p:nvSpPr>
+          <p:cNvPr id="11" name="TextBox 10"/>
+          <p:cNvSpPr txBox="1"/>
+          <p:nvPr/>
+        </p:nvSpPr>
+        <p:spPr>
+          <a:xfrm>
+            <a:off x="1783080" y="2761488"/>
+            <a:ext cx="9052560" cy="384048"/>
+          </a:xfrm>
+          <a:prstGeom prst="rect">
+            <a:avLst/>
+          </a:prstGeom>
+          <a:noFill/>
+        </p:spPr>
+        <p:txBody>
+          <a:bodyPr wrap="square" lIns="36576" rIns="36576" tIns="18288" bIns="18288" anchor="t">
+            <a:spAutoFit/>
+          </a:bodyPr>
+          <a:lstStyle/>
+          <a:p>
+            <a:pPr algn="l">
+              <a:lnSpc>
+                <a:spcPct val="100000"/>
+              </a:lnSpc>
+              <a:spcBef>
+                <a:spcPts val="0"/>
+              </a:spcBef>
+              <a:spcAft>
+                <a:spcPts val="0"/>
+              </a:spcAft>
+            </a:pPr>
+            <a:r>
+              <a:rPr sz="1900" b="0">
                 <a:solidFill>
                   <a:srgbClr val="1F1F1F"/>
                 </a:solidFill>
@@ -3377,13 +3503,13 @@
       </p:sp>
       <p:cxnSp>
         <p:nvCxnSpPr>
-          <p:cNvPr id="9" name="Connector 8"/>
+          <p:cNvPr id="12" name="Connector 11"/>
           <p:cNvCxnSpPr/>
           <p:nvPr/>
         </p:nvCxnSpPr>
         <p:spPr>
           <a:xfrm>
-            <a:off x="1097280" y="2752344"/>
+            <a:off x="1097280" y="3236976"/>
             <a:ext cx="9875520" cy="0"/>
           </a:xfrm>
           <a:prstGeom prst="line">
@@ -3412,14 +3538,14 @@
       </p:cxnSp>
       <p:sp>
         <p:nvSpPr>
-          <p:cNvPr id="10" name="TextBox 9"/>
+          <p:cNvPr id="13" name="TextBox 12"/>
           <p:cNvSpPr txBox="1"/>
           <p:nvPr/>
         </p:nvSpPr>
         <p:spPr>
           <a:xfrm>
-            <a:off x="1097280" y="3090672"/>
-            <a:ext cx="502920" cy="411480"/>
+            <a:off x="1097280" y="3529584"/>
+            <a:ext cx="502920" cy="384048"/>
           </a:xfrm>
           <a:prstGeom prst="rect">
             <a:avLst/>
@@ -3444,27 +3570,27 @@
               </a:spcAft>
             </a:pPr>
             <a:r>
-              <a:rPr sz="2100" b="1">
+              <a:rPr sz="1900" b="1">
                 <a:solidFill>
                   <a:srgbClr val="548235"/>
                 </a:solidFill>
                 <a:latin typeface="Consolas"/>
               </a:rPr>
-              <a:t>4</a:t>
-            </a:r>
-          </a:p>
-        </p:txBody>
-      </p:sp>
-      <p:sp>
-        <p:nvSpPr>
-          <p:cNvPr id="11" name="TextBox 10"/>
+              <a:t>5</a:t>
+            </a:r>
+          </a:p>
+        </p:txBody>
+      </p:sp>
+      <p:sp>
+        <p:nvSpPr>
+          <p:cNvPr id="14" name="TextBox 13"/>
           <p:cNvSpPr txBox="1"/>
           <p:nvPr/>
         </p:nvSpPr>
         <p:spPr>
           <a:xfrm>
-            <a:off x="1783080" y="3090672"/>
-            <a:ext cx="9052560" cy="411480"/>
+            <a:off x="1783080" y="3529584"/>
+            <a:ext cx="9052560" cy="384048"/>
           </a:xfrm>
           <a:prstGeom prst="rect">
             <a:avLst/>
@@ -3489,7 +3615,7 @@
               </a:spcAft>
             </a:pPr>
             <a:r>
-              <a:rPr sz="2100" b="0">
+              <a:rPr sz="1900" b="0">
                 <a:solidFill>
                   <a:srgbClr val="1F1F1F"/>
                 </a:solidFill>
@@ -3502,13 +3628,13 @@
       </p:sp>
       <p:cxnSp>
         <p:nvCxnSpPr>
-          <p:cNvPr id="12" name="Connector 11"/>
+          <p:cNvPr id="15" name="Connector 14"/>
           <p:cNvCxnSpPr/>
           <p:nvPr/>
         </p:nvCxnSpPr>
         <p:spPr>
           <a:xfrm>
-            <a:off x="1097280" y="3621024"/>
+            <a:off x="1097280" y="4005072"/>
             <a:ext cx="9875520" cy="0"/>
           </a:xfrm>
           <a:prstGeom prst="line">
@@ -3537,14 +3663,14 @@
       </p:cxnSp>
       <p:sp>
         <p:nvSpPr>
-          <p:cNvPr id="13" name="TextBox 12"/>
+          <p:cNvPr id="16" name="TextBox 15"/>
           <p:cNvSpPr txBox="1"/>
           <p:nvPr/>
         </p:nvSpPr>
         <p:spPr>
           <a:xfrm>
-            <a:off x="1097280" y="3959352"/>
-            <a:ext cx="502920" cy="411480"/>
+            <a:off x="1097280" y="4297680"/>
+            <a:ext cx="502920" cy="384048"/>
           </a:xfrm>
           <a:prstGeom prst="rect">
             <a:avLst/>
@@ -3569,27 +3695,27 @@
               </a:spcAft>
             </a:pPr>
             <a:r>
-              <a:rPr sz="2100" b="1">
+              <a:rPr sz="1900" b="1">
                 <a:solidFill>
                   <a:srgbClr val="548235"/>
                 </a:solidFill>
                 <a:latin typeface="Consolas"/>
               </a:rPr>
-              <a:t>5</a:t>
-            </a:r>
-          </a:p>
-        </p:txBody>
-      </p:sp>
-      <p:sp>
-        <p:nvSpPr>
-          <p:cNvPr id="14" name="TextBox 13"/>
+              <a:t>6</a:t>
+            </a:r>
+          </a:p>
+        </p:txBody>
+      </p:sp>
+      <p:sp>
+        <p:nvSpPr>
+          <p:cNvPr id="17" name="TextBox 16"/>
           <p:cNvSpPr txBox="1"/>
           <p:nvPr/>
         </p:nvSpPr>
         <p:spPr>
           <a:xfrm>
-            <a:off x="1783080" y="3959352"/>
-            <a:ext cx="9052560" cy="411480"/>
+            <a:off x="1783080" y="4297680"/>
+            <a:ext cx="9052560" cy="384048"/>
           </a:xfrm>
           <a:prstGeom prst="rect">
             <a:avLst/>
@@ -3614,7 +3740,7 @@
               </a:spcAft>
             </a:pPr>
             <a:r>
-              <a:rPr sz="2100" b="0">
+              <a:rPr sz="1900" b="0">
                 <a:solidFill>
                   <a:srgbClr val="1F1F1F"/>
                 </a:solidFill>
@@ -3627,13 +3753,13 @@
       </p:sp>
       <p:cxnSp>
         <p:nvCxnSpPr>
-          <p:cNvPr id="15" name="Connector 14"/>
+          <p:cNvPr id="18" name="Connector 17"/>
           <p:cNvCxnSpPr/>
           <p:nvPr/>
         </p:nvCxnSpPr>
         <p:spPr>
           <a:xfrm>
-            <a:off x="1097280" y="4489704"/>
+            <a:off x="1097280" y="4773168"/>
             <a:ext cx="9875520" cy="0"/>
           </a:xfrm>
           <a:prstGeom prst="line">
@@ -3662,14 +3788,14 @@
       </p:cxnSp>
       <p:sp>
         <p:nvSpPr>
-          <p:cNvPr id="16" name="TextBox 15"/>
+          <p:cNvPr id="19" name="TextBox 18"/>
           <p:cNvSpPr txBox="1"/>
           <p:nvPr/>
         </p:nvSpPr>
         <p:spPr>
           <a:xfrm>
-            <a:off x="1097280" y="4828031"/>
-            <a:ext cx="502920" cy="411480"/>
+            <a:off x="1097280" y="5065776"/>
+            <a:ext cx="502920" cy="384048"/>
           </a:xfrm>
           <a:prstGeom prst="rect">
             <a:avLst/>
@@ -3694,27 +3820,27 @@
               </a:spcAft>
             </a:pPr>
             <a:r>
-              <a:rPr sz="2100" b="1">
+              <a:rPr sz="1900" b="1">
                 <a:solidFill>
                   <a:srgbClr val="548235"/>
                 </a:solidFill>
                 <a:latin typeface="Consolas"/>
               </a:rPr>
-              <a:t>6</a:t>
-            </a:r>
-          </a:p>
-        </p:txBody>
-      </p:sp>
-      <p:sp>
-        <p:nvSpPr>
-          <p:cNvPr id="17" name="TextBox 16"/>
+              <a:t>7</a:t>
+            </a:r>
+          </a:p>
+        </p:txBody>
+      </p:sp>
+      <p:sp>
+        <p:nvSpPr>
+          <p:cNvPr id="20" name="TextBox 19"/>
           <p:cNvSpPr txBox="1"/>
           <p:nvPr/>
         </p:nvSpPr>
         <p:spPr>
           <a:xfrm>
-            <a:off x="1783080" y="4828031"/>
-            <a:ext cx="9052560" cy="411480"/>
+            <a:off x="1783080" y="5065776"/>
+            <a:ext cx="9052560" cy="384048"/>
           </a:xfrm>
           <a:prstGeom prst="rect">
             <a:avLst/>
@@ -3739,7 +3865,7 @@
               </a:spcAft>
             </a:pPr>
             <a:r>
-              <a:rPr sz="2100" b="0">
+              <a:rPr sz="1900" b="0">
                 <a:solidFill>
                   <a:srgbClr val="1F1F1F"/>
                 </a:solidFill>
@@ -3752,13 +3878,13 @@
       </p:sp>
       <p:cxnSp>
         <p:nvCxnSpPr>
-          <p:cNvPr id="18" name="Connector 17"/>
+          <p:cNvPr id="21" name="Connector 20"/>
           <p:cNvCxnSpPr/>
           <p:nvPr/>
         </p:nvCxnSpPr>
         <p:spPr>
           <a:xfrm>
-            <a:off x="1097280" y="5358383"/>
+            <a:off x="1097280" y="5541264"/>
             <a:ext cx="9875520" cy="0"/>
           </a:xfrm>
           <a:prstGeom prst="line">
@@ -3787,7 +3913,7 @@
       </p:cxnSp>
       <p:cxnSp>
         <p:nvCxnSpPr>
-          <p:cNvPr id="19" name="Connector 18"/>
+          <p:cNvPr id="22" name="Connector 21"/>
           <p:cNvCxnSpPr/>
           <p:nvPr/>
         </p:nvCxnSpPr>
@@ -3822,7 +3948,7 @@
       </p:cxnSp>
       <p:sp>
         <p:nvSpPr>
-          <p:cNvPr id="20" name="TextBox 19"/>
+          <p:cNvPr id="23" name="TextBox 22"/>
           <p:cNvSpPr txBox="1"/>
           <p:nvPr/>
         </p:nvSpPr>
@@ -3867,7 +3993,7 @@
       </p:sp>
       <p:sp>
         <p:nvSpPr>
-          <p:cNvPr id="21" name="TextBox 20"/>
+          <p:cNvPr id="24" name="TextBox 23"/>
           <p:cNvSpPr txBox="1"/>
           <p:nvPr/>
         </p:nvSpPr>
@@ -4732,6 +4858,2015 @@
                 </a:solidFill>
                 <a:latin typeface="Aptos"/>
               </a:rPr>
+              <a:t>Original Data Layout Flow</a:t>
+            </a:r>
+          </a:p>
+        </p:txBody>
+      </p:sp>
+      <p:cxnSp>
+        <p:nvCxnSpPr>
+          <p:cNvPr id="3" name="Connector 2"/>
+          <p:cNvCxnSpPr/>
+          <p:nvPr/>
+        </p:nvCxnSpPr>
+        <p:spPr>
+          <a:xfrm>
+            <a:off x="612648" y="868680"/>
+            <a:ext cx="10954512" cy="0"/>
+          </a:xfrm>
+          <a:prstGeom prst="line">
+            <a:avLst/>
+          </a:prstGeom>
+          <a:ln w="17780">
+            <a:solidFill>
+              <a:srgbClr val="548235"/>
+            </a:solidFill>
+          </a:ln>
+        </p:spPr>
+        <p:style>
+          <a:lnRef idx="2">
+            <a:schemeClr val="accent1"/>
+          </a:lnRef>
+          <a:fillRef idx="0">
+            <a:schemeClr val="accent1"/>
+          </a:fillRef>
+          <a:effectRef idx="1">
+            <a:schemeClr val="accent1"/>
+          </a:effectRef>
+          <a:fontRef idx="minor">
+            <a:schemeClr val="tx1"/>
+          </a:fontRef>
+        </p:style>
+      </p:cxnSp>
+      <p:sp>
+        <p:nvSpPr>
+          <p:cNvPr id="4" name="Rectangle 3"/>
+          <p:cNvSpPr/>
+          <p:nvPr/>
+        </p:nvSpPr>
+        <p:spPr>
+          <a:xfrm>
+            <a:off x="502920" y="1783080"/>
+            <a:ext cx="1691640" cy="749808"/>
+          </a:xfrm>
+          <a:prstGeom prst="rect">
+            <a:avLst/>
+          </a:prstGeom>
+          <a:solidFill>
+            <a:srgbClr val="FFFFFF"/>
+          </a:solidFill>
+          <a:ln w="12700">
+            <a:solidFill>
+              <a:srgbClr val="D9D9D9"/>
+            </a:solidFill>
+          </a:ln>
+        </p:spPr>
+        <p:style>
+          <a:lnRef idx="1">
+            <a:schemeClr val="accent1"/>
+          </a:lnRef>
+          <a:fillRef idx="3">
+            <a:schemeClr val="accent1"/>
+          </a:fillRef>
+          <a:effectRef idx="2">
+            <a:schemeClr val="accent1"/>
+          </a:effectRef>
+          <a:fontRef idx="minor">
+            <a:schemeClr val="lt1"/>
+          </a:fontRef>
+        </p:style>
+        <p:txBody>
+          <a:bodyPr rtlCol="0" anchor="ctr"/>
+          <a:lstStyle/>
+          <a:p>
+            <a:pPr algn="ctr"/>
+          </a:p>
+        </p:txBody>
+      </p:sp>
+      <p:sp>
+        <p:nvSpPr>
+          <p:cNvPr id="5" name="TextBox 4"/>
+          <p:cNvSpPr txBox="1"/>
+          <p:nvPr/>
+        </p:nvSpPr>
+        <p:spPr>
+          <a:xfrm>
+            <a:off x="576072" y="1856231"/>
+            <a:ext cx="1545336" cy="603503"/>
+          </a:xfrm>
+          <a:prstGeom prst="rect">
+            <a:avLst/>
+          </a:prstGeom>
+          <a:noFill/>
+        </p:spPr>
+        <p:txBody>
+          <a:bodyPr wrap="square" lIns="36576" rIns="36576" tIns="18288" bIns="18288" anchor="ctr">
+            <a:spAutoFit/>
+          </a:bodyPr>
+          <a:lstStyle/>
+          <a:p>
+            <a:pPr algn="ctr">
+              <a:lnSpc>
+                <a:spcPct val="100000"/>
+              </a:lnSpc>
+              <a:spcBef>
+                <a:spcPts val="0"/>
+              </a:spcBef>
+              <a:spcAft>
+                <a:spcPts val="0"/>
+              </a:spcAft>
+            </a:pPr>
+            <a:r>
+              <a:rPr sz="1300" b="1">
+                <a:solidFill>
+                  <a:srgbClr val="1F1F1F"/>
+                </a:solidFill>
+                <a:latin typeface="Aptos"/>
+              </a:rPr>
+              <a:t>QKV Projection</a:t>
+            </a:r>
+          </a:p>
+          <a:p>
+            <a:pPr algn="ctr">
+              <a:lnSpc>
+                <a:spcPct val="100000"/>
+              </a:lnSpc>
+              <a:spcBef>
+                <a:spcPts val="0"/>
+              </a:spcBef>
+              <a:spcAft>
+                <a:spcPts val="0"/>
+              </a:spcAft>
+            </a:pPr>
+            <a:r>
+              <a:rPr sz="1300" b="1">
+                <a:solidFill>
+                  <a:srgbClr val="1F1F1F"/>
+                </a:solidFill>
+                <a:latin typeface="Aptos"/>
+              </a:rPr>
+              <a:t>+ split</a:t>
+            </a:r>
+          </a:p>
+        </p:txBody>
+      </p:sp>
+      <p:sp>
+        <p:nvSpPr>
+          <p:cNvPr id="6" name="Rectangle 5"/>
+          <p:cNvSpPr/>
+          <p:nvPr/>
+        </p:nvSpPr>
+        <p:spPr>
+          <a:xfrm>
+            <a:off x="2743200" y="1783080"/>
+            <a:ext cx="1691640" cy="749808"/>
+          </a:xfrm>
+          <a:prstGeom prst="rect">
+            <a:avLst/>
+          </a:prstGeom>
+          <a:solidFill>
+            <a:srgbClr val="FFFFFF"/>
+          </a:solidFill>
+          <a:ln w="12700">
+            <a:solidFill>
+              <a:srgbClr val="D9D9D9"/>
+            </a:solidFill>
+          </a:ln>
+        </p:spPr>
+        <p:style>
+          <a:lnRef idx="1">
+            <a:schemeClr val="accent1"/>
+          </a:lnRef>
+          <a:fillRef idx="3">
+            <a:schemeClr val="accent1"/>
+          </a:fillRef>
+          <a:effectRef idx="2">
+            <a:schemeClr val="accent1"/>
+          </a:effectRef>
+          <a:fontRef idx="minor">
+            <a:schemeClr val="lt1"/>
+          </a:fontRef>
+        </p:style>
+        <p:txBody>
+          <a:bodyPr rtlCol="0" anchor="ctr"/>
+          <a:lstStyle/>
+          <a:p>
+            <a:pPr algn="ctr"/>
+          </a:p>
+        </p:txBody>
+      </p:sp>
+      <p:sp>
+        <p:nvSpPr>
+          <p:cNvPr id="7" name="TextBox 6"/>
+          <p:cNvSpPr txBox="1"/>
+          <p:nvPr/>
+        </p:nvSpPr>
+        <p:spPr>
+          <a:xfrm>
+            <a:off x="2816352" y="1856231"/>
+            <a:ext cx="1545336" cy="603503"/>
+          </a:xfrm>
+          <a:prstGeom prst="rect">
+            <a:avLst/>
+          </a:prstGeom>
+          <a:noFill/>
+        </p:spPr>
+        <p:txBody>
+          <a:bodyPr wrap="square" lIns="36576" rIns="36576" tIns="18288" bIns="18288" anchor="ctr">
+            <a:spAutoFit/>
+          </a:bodyPr>
+          <a:lstStyle/>
+          <a:p>
+            <a:pPr algn="ctr">
+              <a:lnSpc>
+                <a:spcPct val="100000"/>
+              </a:lnSpc>
+              <a:spcBef>
+                <a:spcPts val="0"/>
+              </a:spcBef>
+              <a:spcAft>
+                <a:spcPts val="0"/>
+              </a:spcAft>
+            </a:pPr>
+            <a:r>
+              <a:rPr sz="1300" b="1">
+                <a:solidFill>
+                  <a:srgbClr val="1F1F1F"/>
+                </a:solidFill>
+                <a:latin typeface="Aptos"/>
+              </a:rPr>
+              <a:t>Q/K Norm + RoPE</a:t>
+            </a:r>
+          </a:p>
+          <a:p>
+            <a:pPr algn="ctr">
+              <a:lnSpc>
+                <a:spcPct val="100000"/>
+              </a:lnSpc>
+              <a:spcBef>
+                <a:spcPts val="0"/>
+              </a:spcBef>
+              <a:spcAft>
+                <a:spcPts val="0"/>
+              </a:spcAft>
+            </a:pPr>
+            <a:r>
+              <a:rPr sz="1300" b="1">
+                <a:solidFill>
+                  <a:srgbClr val="1F1F1F"/>
+                </a:solidFill>
+                <a:latin typeface="Aptos"/>
+              </a:rPr>
+              <a:t>V bypass</a:t>
+            </a:r>
+          </a:p>
+        </p:txBody>
+      </p:sp>
+      <p:sp>
+        <p:nvSpPr>
+          <p:cNvPr id="8" name="Rectangle 7"/>
+          <p:cNvSpPr/>
+          <p:nvPr/>
+        </p:nvSpPr>
+        <p:spPr>
+          <a:xfrm>
+            <a:off x="4983480" y="1783080"/>
+            <a:ext cx="1691640" cy="749808"/>
+          </a:xfrm>
+          <a:prstGeom prst="rect">
+            <a:avLst/>
+          </a:prstGeom>
+          <a:solidFill>
+            <a:srgbClr val="FFFFFF"/>
+          </a:solidFill>
+          <a:ln w="12700">
+            <a:solidFill>
+              <a:srgbClr val="D9D9D9"/>
+            </a:solidFill>
+          </a:ln>
+        </p:spPr>
+        <p:style>
+          <a:lnRef idx="1">
+            <a:schemeClr val="accent1"/>
+          </a:lnRef>
+          <a:fillRef idx="3">
+            <a:schemeClr val="accent1"/>
+          </a:fillRef>
+          <a:effectRef idx="2">
+            <a:schemeClr val="accent1"/>
+          </a:effectRef>
+          <a:fontRef idx="minor">
+            <a:schemeClr val="lt1"/>
+          </a:fontRef>
+        </p:style>
+        <p:txBody>
+          <a:bodyPr rtlCol="0" anchor="ctr"/>
+          <a:lstStyle/>
+          <a:p>
+            <a:pPr algn="ctr"/>
+          </a:p>
+        </p:txBody>
+      </p:sp>
+      <p:sp>
+        <p:nvSpPr>
+          <p:cNvPr id="9" name="TextBox 8"/>
+          <p:cNvSpPr txBox="1"/>
+          <p:nvPr/>
+        </p:nvSpPr>
+        <p:spPr>
+          <a:xfrm>
+            <a:off x="5056632" y="1856231"/>
+            <a:ext cx="1545336" cy="603503"/>
+          </a:xfrm>
+          <a:prstGeom prst="rect">
+            <a:avLst/>
+          </a:prstGeom>
+          <a:noFill/>
+        </p:spPr>
+        <p:txBody>
+          <a:bodyPr wrap="square" lIns="36576" rIns="36576" tIns="18288" bIns="18288" anchor="ctr">
+            <a:spAutoFit/>
+          </a:bodyPr>
+          <a:lstStyle/>
+          <a:p>
+            <a:pPr algn="ctr">
+              <a:lnSpc>
+                <a:spcPct val="100000"/>
+              </a:lnSpc>
+              <a:spcBef>
+                <a:spcPts val="0"/>
+              </a:spcBef>
+              <a:spcAft>
+                <a:spcPts val="0"/>
+              </a:spcAft>
+            </a:pPr>
+            <a:r>
+              <a:rPr sz="1300" b="1">
+                <a:solidFill>
+                  <a:srgbClr val="1F1F1F"/>
+                </a:solidFill>
+                <a:latin typeface="Aptos"/>
+              </a:rPr>
+              <a:t>Input pack</a:t>
+            </a:r>
+          </a:p>
+        </p:txBody>
+      </p:sp>
+      <p:sp>
+        <p:nvSpPr>
+          <p:cNvPr id="10" name="Rectangle 9"/>
+          <p:cNvSpPr/>
+          <p:nvPr/>
+        </p:nvSpPr>
+        <p:spPr>
+          <a:xfrm>
+            <a:off x="7223760" y="1783080"/>
+            <a:ext cx="1691640" cy="749808"/>
+          </a:xfrm>
+          <a:prstGeom prst="rect">
+            <a:avLst/>
+          </a:prstGeom>
+          <a:solidFill>
+            <a:srgbClr val="FFFFFF"/>
+          </a:solidFill>
+          <a:ln w="12700">
+            <a:solidFill>
+              <a:srgbClr val="D9D9D9"/>
+            </a:solidFill>
+          </a:ln>
+        </p:spPr>
+        <p:style>
+          <a:lnRef idx="1">
+            <a:schemeClr val="accent1"/>
+          </a:lnRef>
+          <a:fillRef idx="3">
+            <a:schemeClr val="accent1"/>
+          </a:fillRef>
+          <a:effectRef idx="2">
+            <a:schemeClr val="accent1"/>
+          </a:effectRef>
+          <a:fontRef idx="minor">
+            <a:schemeClr val="lt1"/>
+          </a:fontRef>
+        </p:style>
+        <p:txBody>
+          <a:bodyPr rtlCol="0" anchor="ctr"/>
+          <a:lstStyle/>
+          <a:p>
+            <a:pPr algn="ctr"/>
+          </a:p>
+        </p:txBody>
+      </p:sp>
+      <p:sp>
+        <p:nvSpPr>
+          <p:cNvPr id="11" name="TextBox 10"/>
+          <p:cNvSpPr txBox="1"/>
+          <p:nvPr/>
+        </p:nvSpPr>
+        <p:spPr>
+          <a:xfrm>
+            <a:off x="7296912" y="1856231"/>
+            <a:ext cx="1545336" cy="603503"/>
+          </a:xfrm>
+          <a:prstGeom prst="rect">
+            <a:avLst/>
+          </a:prstGeom>
+          <a:noFill/>
+        </p:spPr>
+        <p:txBody>
+          <a:bodyPr wrap="square" lIns="36576" rIns="36576" tIns="18288" bIns="18288" anchor="ctr">
+            <a:spAutoFit/>
+          </a:bodyPr>
+          <a:lstStyle/>
+          <a:p>
+            <a:pPr algn="ctr">
+              <a:lnSpc>
+                <a:spcPct val="100000"/>
+              </a:lnSpc>
+              <a:spcBef>
+                <a:spcPts val="0"/>
+              </a:spcBef>
+              <a:spcAft>
+                <a:spcPts val="0"/>
+              </a:spcAft>
+            </a:pPr>
+            <a:r>
+              <a:rPr sz="1300" b="1">
+                <a:solidFill>
+                  <a:srgbClr val="1F1F1F"/>
+                </a:solidFill>
+                <a:latin typeface="Aptos"/>
+              </a:rPr>
+              <a:t>3× NCCL A2A</a:t>
+            </a:r>
+          </a:p>
+        </p:txBody>
+      </p:sp>
+      <p:sp>
+        <p:nvSpPr>
+          <p:cNvPr id="12" name="Rectangle 11"/>
+          <p:cNvSpPr/>
+          <p:nvPr/>
+        </p:nvSpPr>
+        <p:spPr>
+          <a:xfrm>
+            <a:off x="9464040" y="1783080"/>
+            <a:ext cx="1691640" cy="749808"/>
+          </a:xfrm>
+          <a:prstGeom prst="rect">
+            <a:avLst/>
+          </a:prstGeom>
+          <a:solidFill>
+            <a:srgbClr val="FFFFFF"/>
+          </a:solidFill>
+          <a:ln w="12700">
+            <a:solidFill>
+              <a:srgbClr val="D9D9D9"/>
+            </a:solidFill>
+          </a:ln>
+        </p:spPr>
+        <p:style>
+          <a:lnRef idx="1">
+            <a:schemeClr val="accent1"/>
+          </a:lnRef>
+          <a:fillRef idx="3">
+            <a:schemeClr val="accent1"/>
+          </a:fillRef>
+          <a:effectRef idx="2">
+            <a:schemeClr val="accent1"/>
+          </a:effectRef>
+          <a:fontRef idx="minor">
+            <a:schemeClr val="lt1"/>
+          </a:fontRef>
+        </p:style>
+        <p:txBody>
+          <a:bodyPr rtlCol="0" anchor="ctr"/>
+          <a:lstStyle/>
+          <a:p>
+            <a:pPr algn="ctr"/>
+          </a:p>
+        </p:txBody>
+      </p:sp>
+      <p:sp>
+        <p:nvSpPr>
+          <p:cNvPr id="13" name="TextBox 12"/>
+          <p:cNvSpPr txBox="1"/>
+          <p:nvPr/>
+        </p:nvSpPr>
+        <p:spPr>
+          <a:xfrm>
+            <a:off x="9537192" y="1856231"/>
+            <a:ext cx="1545336" cy="603503"/>
+          </a:xfrm>
+          <a:prstGeom prst="rect">
+            <a:avLst/>
+          </a:prstGeom>
+          <a:noFill/>
+        </p:spPr>
+        <p:txBody>
+          <a:bodyPr wrap="square" lIns="36576" rIns="36576" tIns="18288" bIns="18288" anchor="ctr">
+            <a:spAutoFit/>
+          </a:bodyPr>
+          <a:lstStyle/>
+          <a:p>
+            <a:pPr algn="ctr">
+              <a:lnSpc>
+                <a:spcPct val="100000"/>
+              </a:lnSpc>
+              <a:spcBef>
+                <a:spcPts val="0"/>
+              </a:spcBef>
+              <a:spcAft>
+                <a:spcPts val="0"/>
+              </a:spcAft>
+            </a:pPr>
+            <a:r>
+              <a:rPr sz="1300" b="1">
+                <a:solidFill>
+                  <a:srgbClr val="1F1F1F"/>
+                </a:solidFill>
+                <a:latin typeface="Aptos"/>
+              </a:rPr>
+              <a:t>TRTLLM Attention</a:t>
+            </a:r>
+          </a:p>
+        </p:txBody>
+      </p:sp>
+      <p:sp>
+        <p:nvSpPr>
+          <p:cNvPr id="14" name="Right Arrow 13"/>
+          <p:cNvSpPr/>
+          <p:nvPr/>
+        </p:nvSpPr>
+        <p:spPr>
+          <a:xfrm>
+            <a:off x="2231136" y="2029968"/>
+            <a:ext cx="475488" cy="256032"/>
+          </a:xfrm>
+          <a:prstGeom prst="rightArrow">
+            <a:avLst/>
+          </a:prstGeom>
+          <a:solidFill>
+            <a:srgbClr val="548235"/>
+          </a:solidFill>
+          <a:ln>
+            <a:solidFill>
+              <a:srgbClr val="548235"/>
+            </a:solidFill>
+          </a:ln>
+        </p:spPr>
+        <p:style>
+          <a:lnRef idx="1">
+            <a:schemeClr val="accent1"/>
+          </a:lnRef>
+          <a:fillRef idx="3">
+            <a:schemeClr val="accent1"/>
+          </a:fillRef>
+          <a:effectRef idx="2">
+            <a:schemeClr val="accent1"/>
+          </a:effectRef>
+          <a:fontRef idx="minor">
+            <a:schemeClr val="lt1"/>
+          </a:fontRef>
+        </p:style>
+        <p:txBody>
+          <a:bodyPr rtlCol="0" anchor="ctr"/>
+          <a:lstStyle/>
+          <a:p>
+            <a:pPr algn="ctr"/>
+          </a:p>
+        </p:txBody>
+      </p:sp>
+      <p:sp>
+        <p:nvSpPr>
+          <p:cNvPr id="15" name="TextBox 14"/>
+          <p:cNvSpPr txBox="1"/>
+          <p:nvPr/>
+        </p:nvSpPr>
+        <p:spPr>
+          <a:xfrm>
+            <a:off x="1426464" y="1243584"/>
+            <a:ext cx="2084831" cy="365760"/>
+          </a:xfrm>
+          <a:prstGeom prst="rect">
+            <a:avLst/>
+          </a:prstGeom>
+          <a:noFill/>
+        </p:spPr>
+        <p:txBody>
+          <a:bodyPr wrap="square" lIns="36576" rIns="36576" tIns="18288" bIns="18288" anchor="t">
+            <a:spAutoFit/>
+          </a:bodyPr>
+          <a:lstStyle/>
+          <a:p>
+            <a:pPr algn="ctr">
+              <a:lnSpc>
+                <a:spcPct val="100000"/>
+              </a:lnSpc>
+              <a:spcBef>
+                <a:spcPts val="0"/>
+              </a:spcBef>
+              <a:spcAft>
+                <a:spcPts val="0"/>
+              </a:spcAft>
+            </a:pPr>
+            <a:r>
+              <a:rPr sz="900" b="1">
+                <a:solidFill>
+                  <a:srgbClr val="548235"/>
+                </a:solidFill>
+                <a:latin typeface="Consolas"/>
+              </a:rPr>
+              <a:t>[T_local, H, D] ×3</a:t>
+            </a:r>
+          </a:p>
+        </p:txBody>
+      </p:sp>
+      <p:sp>
+        <p:nvSpPr>
+          <p:cNvPr id="16" name="Right Arrow 15"/>
+          <p:cNvSpPr/>
+          <p:nvPr/>
+        </p:nvSpPr>
+        <p:spPr>
+          <a:xfrm>
+            <a:off x="4471416" y="2029968"/>
+            <a:ext cx="475488" cy="256032"/>
+          </a:xfrm>
+          <a:prstGeom prst="rightArrow">
+            <a:avLst/>
+          </a:prstGeom>
+          <a:solidFill>
+            <a:srgbClr val="548235"/>
+          </a:solidFill>
+          <a:ln>
+            <a:solidFill>
+              <a:srgbClr val="548235"/>
+            </a:solidFill>
+          </a:ln>
+        </p:spPr>
+        <p:style>
+          <a:lnRef idx="1">
+            <a:schemeClr val="accent1"/>
+          </a:lnRef>
+          <a:fillRef idx="3">
+            <a:schemeClr val="accent1"/>
+          </a:fillRef>
+          <a:effectRef idx="2">
+            <a:schemeClr val="accent1"/>
+          </a:effectRef>
+          <a:fontRef idx="minor">
+            <a:schemeClr val="lt1"/>
+          </a:fontRef>
+        </p:style>
+        <p:txBody>
+          <a:bodyPr rtlCol="0" anchor="ctr"/>
+          <a:lstStyle/>
+          <a:p>
+            <a:pPr algn="ctr"/>
+          </a:p>
+        </p:txBody>
+      </p:sp>
+      <p:sp>
+        <p:nvSpPr>
+          <p:cNvPr id="17" name="TextBox 16"/>
+          <p:cNvSpPr txBox="1"/>
+          <p:nvPr/>
+        </p:nvSpPr>
+        <p:spPr>
+          <a:xfrm>
+            <a:off x="3666744" y="1243584"/>
+            <a:ext cx="2084831" cy="365760"/>
+          </a:xfrm>
+          <a:prstGeom prst="rect">
+            <a:avLst/>
+          </a:prstGeom>
+          <a:noFill/>
+        </p:spPr>
+        <p:txBody>
+          <a:bodyPr wrap="square" lIns="36576" rIns="36576" tIns="18288" bIns="18288" anchor="t">
+            <a:spAutoFit/>
+          </a:bodyPr>
+          <a:lstStyle/>
+          <a:p>
+            <a:pPr algn="ctr">
+              <a:lnSpc>
+                <a:spcPct val="100000"/>
+              </a:lnSpc>
+              <a:spcBef>
+                <a:spcPts val="0"/>
+              </a:spcBef>
+              <a:spcAft>
+                <a:spcPts val="0"/>
+              </a:spcAft>
+            </a:pPr>
+            <a:r>
+              <a:rPr sz="900" b="1">
+                <a:solidFill>
+                  <a:srgbClr val="548235"/>
+                </a:solidFill>
+                <a:latin typeface="Consolas"/>
+              </a:rPr>
+              <a:t>[B, T_local, H, D]</a:t>
+            </a:r>
+          </a:p>
+        </p:txBody>
+      </p:sp>
+      <p:sp>
+        <p:nvSpPr>
+          <p:cNvPr id="18" name="Right Arrow 17"/>
+          <p:cNvSpPr/>
+          <p:nvPr/>
+        </p:nvSpPr>
+        <p:spPr>
+          <a:xfrm>
+            <a:off x="6711696" y="2029968"/>
+            <a:ext cx="475488" cy="256032"/>
+          </a:xfrm>
+          <a:prstGeom prst="rightArrow">
+            <a:avLst/>
+          </a:prstGeom>
+          <a:solidFill>
+            <a:srgbClr val="548235"/>
+          </a:solidFill>
+          <a:ln>
+            <a:solidFill>
+              <a:srgbClr val="548235"/>
+            </a:solidFill>
+          </a:ln>
+        </p:spPr>
+        <p:style>
+          <a:lnRef idx="1">
+            <a:schemeClr val="accent1"/>
+          </a:lnRef>
+          <a:fillRef idx="3">
+            <a:schemeClr val="accent1"/>
+          </a:fillRef>
+          <a:effectRef idx="2">
+            <a:schemeClr val="accent1"/>
+          </a:effectRef>
+          <a:fontRef idx="minor">
+            <a:schemeClr val="lt1"/>
+          </a:fontRef>
+        </p:style>
+        <p:txBody>
+          <a:bodyPr rtlCol="0" anchor="ctr"/>
+          <a:lstStyle/>
+          <a:p>
+            <a:pPr algn="ctr"/>
+          </a:p>
+        </p:txBody>
+      </p:sp>
+      <p:sp>
+        <p:nvSpPr>
+          <p:cNvPr id="19" name="TextBox 18"/>
+          <p:cNvSpPr txBox="1"/>
+          <p:nvPr/>
+        </p:nvSpPr>
+        <p:spPr>
+          <a:xfrm>
+            <a:off x="5907024" y="1243584"/>
+            <a:ext cx="2084831" cy="365760"/>
+          </a:xfrm>
+          <a:prstGeom prst="rect">
+            <a:avLst/>
+          </a:prstGeom>
+          <a:noFill/>
+        </p:spPr>
+        <p:txBody>
+          <a:bodyPr wrap="square" lIns="36576" rIns="36576" tIns="18288" bIns="18288" anchor="t">
+            <a:spAutoFit/>
+          </a:bodyPr>
+          <a:lstStyle/>
+          <a:p>
+            <a:pPr algn="ctr">
+              <a:lnSpc>
+                <a:spcPct val="100000"/>
+              </a:lnSpc>
+              <a:spcBef>
+                <a:spcPts val="0"/>
+              </a:spcBef>
+              <a:spcAft>
+                <a:spcPts val="0"/>
+              </a:spcAft>
+            </a:pPr>
+            <a:r>
+              <a:rPr sz="900" b="1">
+                <a:solidFill>
+                  <a:srgbClr val="548235"/>
+                </a:solidFill>
+                <a:latin typeface="Consolas"/>
+              </a:rPr>
+              <a:t>[P, T_local, B, H/P, D]</a:t>
+            </a:r>
+          </a:p>
+        </p:txBody>
+      </p:sp>
+      <p:sp>
+        <p:nvSpPr>
+          <p:cNvPr id="20" name="Right Arrow 19"/>
+          <p:cNvSpPr/>
+          <p:nvPr/>
+        </p:nvSpPr>
+        <p:spPr>
+          <a:xfrm>
+            <a:off x="8951976" y="2029968"/>
+            <a:ext cx="475488" cy="256032"/>
+          </a:xfrm>
+          <a:prstGeom prst="rightArrow">
+            <a:avLst/>
+          </a:prstGeom>
+          <a:solidFill>
+            <a:srgbClr val="548235"/>
+          </a:solidFill>
+          <a:ln>
+            <a:solidFill>
+              <a:srgbClr val="548235"/>
+            </a:solidFill>
+          </a:ln>
+        </p:spPr>
+        <p:style>
+          <a:lnRef idx="1">
+            <a:schemeClr val="accent1"/>
+          </a:lnRef>
+          <a:fillRef idx="3">
+            <a:schemeClr val="accent1"/>
+          </a:fillRef>
+          <a:effectRef idx="2">
+            <a:schemeClr val="accent1"/>
+          </a:effectRef>
+          <a:fontRef idx="minor">
+            <a:schemeClr val="lt1"/>
+          </a:fontRef>
+        </p:style>
+        <p:txBody>
+          <a:bodyPr rtlCol="0" anchor="ctr"/>
+          <a:lstStyle/>
+          <a:p>
+            <a:pPr algn="ctr"/>
+          </a:p>
+        </p:txBody>
+      </p:sp>
+      <p:sp>
+        <p:nvSpPr>
+          <p:cNvPr id="21" name="TextBox 20"/>
+          <p:cNvSpPr txBox="1"/>
+          <p:nvPr/>
+        </p:nvSpPr>
+        <p:spPr>
+          <a:xfrm>
+            <a:off x="8147304" y="1243584"/>
+            <a:ext cx="2084831" cy="365760"/>
+          </a:xfrm>
+          <a:prstGeom prst="rect">
+            <a:avLst/>
+          </a:prstGeom>
+          <a:noFill/>
+        </p:spPr>
+        <p:txBody>
+          <a:bodyPr wrap="square" lIns="36576" rIns="36576" tIns="18288" bIns="18288" anchor="t">
+            <a:spAutoFit/>
+          </a:bodyPr>
+          <a:lstStyle/>
+          <a:p>
+            <a:pPr algn="ctr">
+              <a:lnSpc>
+                <a:spcPct val="100000"/>
+              </a:lnSpc>
+              <a:spcBef>
+                <a:spcPts val="0"/>
+              </a:spcBef>
+              <a:spcAft>
+                <a:spcPts val="0"/>
+              </a:spcAft>
+            </a:pPr>
+            <a:r>
+              <a:rPr sz="900" b="1">
+                <a:solidFill>
+                  <a:srgbClr val="548235"/>
+                </a:solidFill>
+                <a:latin typeface="Consolas"/>
+              </a:rPr>
+              <a:t>[B, T_global, H/P, D]</a:t>
+            </a:r>
+          </a:p>
+        </p:txBody>
+      </p:sp>
+      <p:sp>
+        <p:nvSpPr>
+          <p:cNvPr id="22" name="Down Arrow 21"/>
+          <p:cNvSpPr/>
+          <p:nvPr/>
+        </p:nvSpPr>
+        <p:spPr>
+          <a:xfrm>
+            <a:off x="10168128" y="2770632"/>
+            <a:ext cx="292608" cy="694944"/>
+          </a:xfrm>
+          <a:prstGeom prst="downArrow">
+            <a:avLst/>
+          </a:prstGeom>
+          <a:solidFill>
+            <a:srgbClr val="548235"/>
+          </a:solidFill>
+          <a:ln>
+            <a:solidFill>
+              <a:srgbClr val="548235"/>
+            </a:solidFill>
+          </a:ln>
+        </p:spPr>
+        <p:style>
+          <a:lnRef idx="1">
+            <a:schemeClr val="accent1"/>
+          </a:lnRef>
+          <a:fillRef idx="3">
+            <a:schemeClr val="accent1"/>
+          </a:fillRef>
+          <a:effectRef idx="2">
+            <a:schemeClr val="accent1"/>
+          </a:effectRef>
+          <a:fontRef idx="minor">
+            <a:schemeClr val="lt1"/>
+          </a:fontRef>
+        </p:style>
+        <p:txBody>
+          <a:bodyPr rtlCol="0" anchor="ctr"/>
+          <a:lstStyle/>
+          <a:p>
+            <a:pPr algn="ctr"/>
+          </a:p>
+        </p:txBody>
+      </p:sp>
+      <p:sp>
+        <p:nvSpPr>
+          <p:cNvPr id="23" name="TextBox 22"/>
+          <p:cNvSpPr txBox="1"/>
+          <p:nvPr/>
+        </p:nvSpPr>
+        <p:spPr>
+          <a:xfrm>
+            <a:off x="8412480" y="2962656"/>
+            <a:ext cx="1645920" cy="365760"/>
+          </a:xfrm>
+          <a:prstGeom prst="rect">
+            <a:avLst/>
+          </a:prstGeom>
+          <a:noFill/>
+        </p:spPr>
+        <p:txBody>
+          <a:bodyPr wrap="square" lIns="36576" rIns="36576" tIns="18288" bIns="18288" anchor="t">
+            <a:spAutoFit/>
+          </a:bodyPr>
+          <a:lstStyle/>
+          <a:p>
+            <a:pPr algn="r">
+              <a:lnSpc>
+                <a:spcPct val="100000"/>
+              </a:lnSpc>
+              <a:spcBef>
+                <a:spcPts val="0"/>
+              </a:spcBef>
+              <a:spcAft>
+                <a:spcPts val="0"/>
+              </a:spcAft>
+            </a:pPr>
+            <a:r>
+              <a:rPr sz="900" b="1">
+                <a:solidFill>
+                  <a:srgbClr val="548235"/>
+                </a:solidFill>
+                <a:latin typeface="Consolas"/>
+              </a:rPr>
+              <a:t>[B, T_global, H/P, D]</a:t>
+            </a:r>
+          </a:p>
+        </p:txBody>
+      </p:sp>
+      <p:sp>
+        <p:nvSpPr>
+          <p:cNvPr id="24" name="Rectangle 23"/>
+          <p:cNvSpPr/>
+          <p:nvPr/>
+        </p:nvSpPr>
+        <p:spPr>
+          <a:xfrm>
+            <a:off x="9464040" y="4069080"/>
+            <a:ext cx="1691640" cy="749808"/>
+          </a:xfrm>
+          <a:prstGeom prst="rect">
+            <a:avLst/>
+          </a:prstGeom>
+          <a:solidFill>
+            <a:srgbClr val="FFFFFF"/>
+          </a:solidFill>
+          <a:ln w="12700">
+            <a:solidFill>
+              <a:srgbClr val="D9D9D9"/>
+            </a:solidFill>
+          </a:ln>
+        </p:spPr>
+        <p:style>
+          <a:lnRef idx="1">
+            <a:schemeClr val="accent1"/>
+          </a:lnRef>
+          <a:fillRef idx="3">
+            <a:schemeClr val="accent1"/>
+          </a:fillRef>
+          <a:effectRef idx="2">
+            <a:schemeClr val="accent1"/>
+          </a:effectRef>
+          <a:fontRef idx="minor">
+            <a:schemeClr val="lt1"/>
+          </a:fontRef>
+        </p:style>
+        <p:txBody>
+          <a:bodyPr rtlCol="0" anchor="ctr"/>
+          <a:lstStyle/>
+          <a:p>
+            <a:pPr algn="ctr"/>
+          </a:p>
+        </p:txBody>
+      </p:sp>
+      <p:sp>
+        <p:nvSpPr>
+          <p:cNvPr id="25" name="TextBox 24"/>
+          <p:cNvSpPr txBox="1"/>
+          <p:nvPr/>
+        </p:nvSpPr>
+        <p:spPr>
+          <a:xfrm>
+            <a:off x="9537192" y="4142232"/>
+            <a:ext cx="1545336" cy="603503"/>
+          </a:xfrm>
+          <a:prstGeom prst="rect">
+            <a:avLst/>
+          </a:prstGeom>
+          <a:noFill/>
+        </p:spPr>
+        <p:txBody>
+          <a:bodyPr wrap="square" lIns="36576" rIns="36576" tIns="18288" bIns="18288" anchor="ctr">
+            <a:spAutoFit/>
+          </a:bodyPr>
+          <a:lstStyle/>
+          <a:p>
+            <a:pPr algn="ctr">
+              <a:lnSpc>
+                <a:spcPct val="100000"/>
+              </a:lnSpc>
+              <a:spcBef>
+                <a:spcPts val="0"/>
+              </a:spcBef>
+              <a:spcAft>
+                <a:spcPts val="0"/>
+              </a:spcAft>
+            </a:pPr>
+            <a:r>
+              <a:rPr sz="1300" b="1">
+                <a:solidFill>
+                  <a:srgbClr val="1F1F1F"/>
+                </a:solidFill>
+                <a:latin typeface="Aptos"/>
+              </a:rPr>
+              <a:t>Output pack</a:t>
+            </a:r>
+          </a:p>
+        </p:txBody>
+      </p:sp>
+      <p:sp>
+        <p:nvSpPr>
+          <p:cNvPr id="26" name="Rectangle 25"/>
+          <p:cNvSpPr/>
+          <p:nvPr/>
+        </p:nvSpPr>
+        <p:spPr>
+          <a:xfrm>
+            <a:off x="7223760" y="4069080"/>
+            <a:ext cx="1691640" cy="749808"/>
+          </a:xfrm>
+          <a:prstGeom prst="rect">
+            <a:avLst/>
+          </a:prstGeom>
+          <a:solidFill>
+            <a:srgbClr val="FFFFFF"/>
+          </a:solidFill>
+          <a:ln w="12700">
+            <a:solidFill>
+              <a:srgbClr val="D9D9D9"/>
+            </a:solidFill>
+          </a:ln>
+        </p:spPr>
+        <p:style>
+          <a:lnRef idx="1">
+            <a:schemeClr val="accent1"/>
+          </a:lnRef>
+          <a:fillRef idx="3">
+            <a:schemeClr val="accent1"/>
+          </a:fillRef>
+          <a:effectRef idx="2">
+            <a:schemeClr val="accent1"/>
+          </a:effectRef>
+          <a:fontRef idx="minor">
+            <a:schemeClr val="lt1"/>
+          </a:fontRef>
+        </p:style>
+        <p:txBody>
+          <a:bodyPr rtlCol="0" anchor="ctr"/>
+          <a:lstStyle/>
+          <a:p>
+            <a:pPr algn="ctr"/>
+          </a:p>
+        </p:txBody>
+      </p:sp>
+      <p:sp>
+        <p:nvSpPr>
+          <p:cNvPr id="27" name="TextBox 26"/>
+          <p:cNvSpPr txBox="1"/>
+          <p:nvPr/>
+        </p:nvSpPr>
+        <p:spPr>
+          <a:xfrm>
+            <a:off x="7296912" y="4142232"/>
+            <a:ext cx="1545336" cy="603503"/>
+          </a:xfrm>
+          <a:prstGeom prst="rect">
+            <a:avLst/>
+          </a:prstGeom>
+          <a:noFill/>
+        </p:spPr>
+        <p:txBody>
+          <a:bodyPr wrap="square" lIns="36576" rIns="36576" tIns="18288" bIns="18288" anchor="ctr">
+            <a:spAutoFit/>
+          </a:bodyPr>
+          <a:lstStyle/>
+          <a:p>
+            <a:pPr algn="ctr">
+              <a:lnSpc>
+                <a:spcPct val="100000"/>
+              </a:lnSpc>
+              <a:spcBef>
+                <a:spcPts val="0"/>
+              </a:spcBef>
+              <a:spcAft>
+                <a:spcPts val="0"/>
+              </a:spcAft>
+            </a:pPr>
+            <a:r>
+              <a:rPr sz="1300" b="1">
+                <a:solidFill>
+                  <a:srgbClr val="1F1F1F"/>
+                </a:solidFill>
+                <a:latin typeface="Aptos"/>
+              </a:rPr>
+              <a:t>NCCL A2A</a:t>
+            </a:r>
+          </a:p>
+        </p:txBody>
+      </p:sp>
+      <p:sp>
+        <p:nvSpPr>
+          <p:cNvPr id="28" name="Rectangle 27"/>
+          <p:cNvSpPr/>
+          <p:nvPr/>
+        </p:nvSpPr>
+        <p:spPr>
+          <a:xfrm>
+            <a:off x="4983480" y="4069080"/>
+            <a:ext cx="1691640" cy="749808"/>
+          </a:xfrm>
+          <a:prstGeom prst="rect">
+            <a:avLst/>
+          </a:prstGeom>
+          <a:solidFill>
+            <a:srgbClr val="FFFFFF"/>
+          </a:solidFill>
+          <a:ln w="12700">
+            <a:solidFill>
+              <a:srgbClr val="D9D9D9"/>
+            </a:solidFill>
+          </a:ln>
+        </p:spPr>
+        <p:style>
+          <a:lnRef idx="1">
+            <a:schemeClr val="accent1"/>
+          </a:lnRef>
+          <a:fillRef idx="3">
+            <a:schemeClr val="accent1"/>
+          </a:fillRef>
+          <a:effectRef idx="2">
+            <a:schemeClr val="accent1"/>
+          </a:effectRef>
+          <a:fontRef idx="minor">
+            <a:schemeClr val="lt1"/>
+          </a:fontRef>
+        </p:style>
+        <p:txBody>
+          <a:bodyPr rtlCol="0" anchor="ctr"/>
+          <a:lstStyle/>
+          <a:p>
+            <a:pPr algn="ctr"/>
+          </a:p>
+        </p:txBody>
+      </p:sp>
+      <p:sp>
+        <p:nvSpPr>
+          <p:cNvPr id="29" name="TextBox 28"/>
+          <p:cNvSpPr txBox="1"/>
+          <p:nvPr/>
+        </p:nvSpPr>
+        <p:spPr>
+          <a:xfrm>
+            <a:off x="5056632" y="4142232"/>
+            <a:ext cx="1545336" cy="603503"/>
+          </a:xfrm>
+          <a:prstGeom prst="rect">
+            <a:avLst/>
+          </a:prstGeom>
+          <a:noFill/>
+        </p:spPr>
+        <p:txBody>
+          <a:bodyPr wrap="square" lIns="36576" rIns="36576" tIns="18288" bIns="18288" anchor="ctr">
+            <a:spAutoFit/>
+          </a:bodyPr>
+          <a:lstStyle/>
+          <a:p>
+            <a:pPr algn="ctr">
+              <a:lnSpc>
+                <a:spcPct val="100000"/>
+              </a:lnSpc>
+              <a:spcBef>
+                <a:spcPts val="0"/>
+              </a:spcBef>
+              <a:spcAft>
+                <a:spcPts val="0"/>
+              </a:spcAft>
+            </a:pPr>
+            <a:r>
+              <a:rPr sz="1300" b="1">
+                <a:solidFill>
+                  <a:srgbClr val="1F1F1F"/>
+                </a:solidFill>
+                <a:latin typeface="Aptos"/>
+              </a:rPr>
+              <a:t>Output unpack</a:t>
+            </a:r>
+          </a:p>
+        </p:txBody>
+      </p:sp>
+      <p:sp>
+        <p:nvSpPr>
+          <p:cNvPr id="30" name="Rectangle 29"/>
+          <p:cNvSpPr/>
+          <p:nvPr/>
+        </p:nvSpPr>
+        <p:spPr>
+          <a:xfrm>
+            <a:off x="2743200" y="4069080"/>
+            <a:ext cx="1691640" cy="749808"/>
+          </a:xfrm>
+          <a:prstGeom prst="rect">
+            <a:avLst/>
+          </a:prstGeom>
+          <a:solidFill>
+            <a:srgbClr val="FFFFFF"/>
+          </a:solidFill>
+          <a:ln w="12700">
+            <a:solidFill>
+              <a:srgbClr val="D9D9D9"/>
+            </a:solidFill>
+          </a:ln>
+        </p:spPr>
+        <p:style>
+          <a:lnRef idx="1">
+            <a:schemeClr val="accent1"/>
+          </a:lnRef>
+          <a:fillRef idx="3">
+            <a:schemeClr val="accent1"/>
+          </a:fillRef>
+          <a:effectRef idx="2">
+            <a:schemeClr val="accent1"/>
+          </a:effectRef>
+          <a:fontRef idx="minor">
+            <a:schemeClr val="lt1"/>
+          </a:fontRef>
+        </p:style>
+        <p:txBody>
+          <a:bodyPr rtlCol="0" anchor="ctr"/>
+          <a:lstStyle/>
+          <a:p>
+            <a:pPr algn="ctr"/>
+          </a:p>
+        </p:txBody>
+      </p:sp>
+      <p:sp>
+        <p:nvSpPr>
+          <p:cNvPr id="31" name="TextBox 30"/>
+          <p:cNvSpPr txBox="1"/>
+          <p:nvPr/>
+        </p:nvSpPr>
+        <p:spPr>
+          <a:xfrm>
+            <a:off x="2816352" y="4142232"/>
+            <a:ext cx="1545336" cy="603503"/>
+          </a:xfrm>
+          <a:prstGeom prst="rect">
+            <a:avLst/>
+          </a:prstGeom>
+          <a:noFill/>
+        </p:spPr>
+        <p:txBody>
+          <a:bodyPr wrap="square" lIns="36576" rIns="36576" tIns="18288" bIns="18288" anchor="ctr">
+            <a:spAutoFit/>
+          </a:bodyPr>
+          <a:lstStyle/>
+          <a:p>
+            <a:pPr algn="ctr">
+              <a:lnSpc>
+                <a:spcPct val="100000"/>
+              </a:lnSpc>
+              <a:spcBef>
+                <a:spcPts val="0"/>
+              </a:spcBef>
+              <a:spcAft>
+                <a:spcPts val="0"/>
+              </a:spcAft>
+            </a:pPr>
+            <a:r>
+              <a:rPr sz="1300" b="1">
+                <a:solidFill>
+                  <a:srgbClr val="1F1F1F"/>
+                </a:solidFill>
+                <a:latin typeface="Aptos"/>
+              </a:rPr>
+              <a:t>Out Projection</a:t>
+            </a:r>
+          </a:p>
+        </p:txBody>
+      </p:sp>
+      <p:sp>
+        <p:nvSpPr>
+          <p:cNvPr id="32" name="Rectangle 31"/>
+          <p:cNvSpPr/>
+          <p:nvPr/>
+        </p:nvSpPr>
+        <p:spPr>
+          <a:xfrm>
+            <a:off x="502920" y="4069080"/>
+            <a:ext cx="1691640" cy="749808"/>
+          </a:xfrm>
+          <a:prstGeom prst="rect">
+            <a:avLst/>
+          </a:prstGeom>
+          <a:solidFill>
+            <a:srgbClr val="FFFFFF"/>
+          </a:solidFill>
+          <a:ln w="12700">
+            <a:solidFill>
+              <a:srgbClr val="D9D9D9"/>
+            </a:solidFill>
+          </a:ln>
+        </p:spPr>
+        <p:style>
+          <a:lnRef idx="1">
+            <a:schemeClr val="accent1"/>
+          </a:lnRef>
+          <a:fillRef idx="3">
+            <a:schemeClr val="accent1"/>
+          </a:fillRef>
+          <a:effectRef idx="2">
+            <a:schemeClr val="accent1"/>
+          </a:effectRef>
+          <a:fontRef idx="minor">
+            <a:schemeClr val="lt1"/>
+          </a:fontRef>
+        </p:style>
+        <p:txBody>
+          <a:bodyPr rtlCol="0" anchor="ctr"/>
+          <a:lstStyle/>
+          <a:p>
+            <a:pPr algn="ctr"/>
+          </a:p>
+        </p:txBody>
+      </p:sp>
+      <p:sp>
+        <p:nvSpPr>
+          <p:cNvPr id="33" name="TextBox 32"/>
+          <p:cNvSpPr txBox="1"/>
+          <p:nvPr/>
+        </p:nvSpPr>
+        <p:spPr>
+          <a:xfrm>
+            <a:off x="576072" y="4142232"/>
+            <a:ext cx="1545336" cy="603503"/>
+          </a:xfrm>
+          <a:prstGeom prst="rect">
+            <a:avLst/>
+          </a:prstGeom>
+          <a:noFill/>
+        </p:spPr>
+        <p:txBody>
+          <a:bodyPr wrap="square" lIns="36576" rIns="36576" tIns="18288" bIns="18288" anchor="ctr">
+            <a:spAutoFit/>
+          </a:bodyPr>
+          <a:lstStyle/>
+          <a:p>
+            <a:pPr algn="ctr">
+              <a:lnSpc>
+                <a:spcPct val="100000"/>
+              </a:lnSpc>
+              <a:spcBef>
+                <a:spcPts val="0"/>
+              </a:spcBef>
+              <a:spcAft>
+                <a:spcPts val="0"/>
+              </a:spcAft>
+            </a:pPr>
+            <a:r>
+              <a:rPr sz="1300" b="1">
+                <a:solidFill>
+                  <a:srgbClr val="1F1F1F"/>
+                </a:solidFill>
+                <a:latin typeface="Aptos"/>
+              </a:rPr>
+              <a:t>Block output</a:t>
+            </a:r>
+          </a:p>
+        </p:txBody>
+      </p:sp>
+      <p:sp>
+        <p:nvSpPr>
+          <p:cNvPr id="34" name="Left Arrow 33"/>
+          <p:cNvSpPr/>
+          <p:nvPr/>
+        </p:nvSpPr>
+        <p:spPr>
+          <a:xfrm>
+            <a:off x="8951976" y="4315968"/>
+            <a:ext cx="475488" cy="256032"/>
+          </a:xfrm>
+          <a:prstGeom prst="leftArrow">
+            <a:avLst/>
+          </a:prstGeom>
+          <a:solidFill>
+            <a:srgbClr val="548235"/>
+          </a:solidFill>
+          <a:ln>
+            <a:solidFill>
+              <a:srgbClr val="548235"/>
+            </a:solidFill>
+          </a:ln>
+        </p:spPr>
+        <p:style>
+          <a:lnRef idx="1">
+            <a:schemeClr val="accent1"/>
+          </a:lnRef>
+          <a:fillRef idx="3">
+            <a:schemeClr val="accent1"/>
+          </a:fillRef>
+          <a:effectRef idx="2">
+            <a:schemeClr val="accent1"/>
+          </a:effectRef>
+          <a:fontRef idx="minor">
+            <a:schemeClr val="lt1"/>
+          </a:fontRef>
+        </p:style>
+        <p:txBody>
+          <a:bodyPr rtlCol="0" anchor="ctr"/>
+          <a:lstStyle/>
+          <a:p>
+            <a:pPr algn="ctr"/>
+          </a:p>
+        </p:txBody>
+      </p:sp>
+      <p:sp>
+        <p:nvSpPr>
+          <p:cNvPr id="35" name="TextBox 34"/>
+          <p:cNvSpPr txBox="1"/>
+          <p:nvPr/>
+        </p:nvSpPr>
+        <p:spPr>
+          <a:xfrm>
+            <a:off x="8147303" y="3547872"/>
+            <a:ext cx="2084831" cy="365760"/>
+          </a:xfrm>
+          <a:prstGeom prst="rect">
+            <a:avLst/>
+          </a:prstGeom>
+          <a:noFill/>
+        </p:spPr>
+        <p:txBody>
+          <a:bodyPr wrap="square" lIns="36576" rIns="36576" tIns="18288" bIns="18288" anchor="t">
+            <a:spAutoFit/>
+          </a:bodyPr>
+          <a:lstStyle/>
+          <a:p>
+            <a:pPr algn="ctr">
+              <a:lnSpc>
+                <a:spcPct val="100000"/>
+              </a:lnSpc>
+              <a:spcBef>
+                <a:spcPts val="0"/>
+              </a:spcBef>
+              <a:spcAft>
+                <a:spcPts val="0"/>
+              </a:spcAft>
+            </a:pPr>
+            <a:r>
+              <a:rPr sz="900" b="1">
+                <a:solidFill>
+                  <a:srgbClr val="548235"/>
+                </a:solidFill>
+                <a:latin typeface="Consolas"/>
+              </a:rPr>
+              <a:t>[P, H/P, T_local, B, D]</a:t>
+            </a:r>
+          </a:p>
+        </p:txBody>
+      </p:sp>
+      <p:sp>
+        <p:nvSpPr>
+          <p:cNvPr id="36" name="Left Arrow 35"/>
+          <p:cNvSpPr/>
+          <p:nvPr/>
+        </p:nvSpPr>
+        <p:spPr>
+          <a:xfrm>
+            <a:off x="6711696" y="4315968"/>
+            <a:ext cx="475488" cy="256032"/>
+          </a:xfrm>
+          <a:prstGeom prst="leftArrow">
+            <a:avLst/>
+          </a:prstGeom>
+          <a:solidFill>
+            <a:srgbClr val="548235"/>
+          </a:solidFill>
+          <a:ln>
+            <a:solidFill>
+              <a:srgbClr val="548235"/>
+            </a:solidFill>
+          </a:ln>
+        </p:spPr>
+        <p:style>
+          <a:lnRef idx="1">
+            <a:schemeClr val="accent1"/>
+          </a:lnRef>
+          <a:fillRef idx="3">
+            <a:schemeClr val="accent1"/>
+          </a:fillRef>
+          <a:effectRef idx="2">
+            <a:schemeClr val="accent1"/>
+          </a:effectRef>
+          <a:fontRef idx="minor">
+            <a:schemeClr val="lt1"/>
+          </a:fontRef>
+        </p:style>
+        <p:txBody>
+          <a:bodyPr rtlCol="0" anchor="ctr"/>
+          <a:lstStyle/>
+          <a:p>
+            <a:pPr algn="ctr"/>
+          </a:p>
+        </p:txBody>
+      </p:sp>
+      <p:sp>
+        <p:nvSpPr>
+          <p:cNvPr id="37" name="TextBox 36"/>
+          <p:cNvSpPr txBox="1"/>
+          <p:nvPr/>
+        </p:nvSpPr>
+        <p:spPr>
+          <a:xfrm>
+            <a:off x="5907024" y="3547872"/>
+            <a:ext cx="2084831" cy="365760"/>
+          </a:xfrm>
+          <a:prstGeom prst="rect">
+            <a:avLst/>
+          </a:prstGeom>
+          <a:noFill/>
+        </p:spPr>
+        <p:txBody>
+          <a:bodyPr wrap="square" lIns="36576" rIns="36576" tIns="18288" bIns="18288" anchor="t">
+            <a:spAutoFit/>
+          </a:bodyPr>
+          <a:lstStyle/>
+          <a:p>
+            <a:pPr algn="ctr">
+              <a:lnSpc>
+                <a:spcPct val="100000"/>
+              </a:lnSpc>
+              <a:spcBef>
+                <a:spcPts val="0"/>
+              </a:spcBef>
+              <a:spcAft>
+                <a:spcPts val="0"/>
+              </a:spcAft>
+            </a:pPr>
+            <a:r>
+              <a:rPr sz="900" b="1">
+                <a:solidFill>
+                  <a:srgbClr val="548235"/>
+                </a:solidFill>
+                <a:latin typeface="Consolas"/>
+              </a:rPr>
+              <a:t>[P, H/P, T_local, B, D]</a:t>
+            </a:r>
+          </a:p>
+        </p:txBody>
+      </p:sp>
+      <p:sp>
+        <p:nvSpPr>
+          <p:cNvPr id="38" name="Left Arrow 37"/>
+          <p:cNvSpPr/>
+          <p:nvPr/>
+        </p:nvSpPr>
+        <p:spPr>
+          <a:xfrm>
+            <a:off x="4471416" y="4315968"/>
+            <a:ext cx="475488" cy="256032"/>
+          </a:xfrm>
+          <a:prstGeom prst="leftArrow">
+            <a:avLst/>
+          </a:prstGeom>
+          <a:solidFill>
+            <a:srgbClr val="548235"/>
+          </a:solidFill>
+          <a:ln>
+            <a:solidFill>
+              <a:srgbClr val="548235"/>
+            </a:solidFill>
+          </a:ln>
+        </p:spPr>
+        <p:style>
+          <a:lnRef idx="1">
+            <a:schemeClr val="accent1"/>
+          </a:lnRef>
+          <a:fillRef idx="3">
+            <a:schemeClr val="accent1"/>
+          </a:fillRef>
+          <a:effectRef idx="2">
+            <a:schemeClr val="accent1"/>
+          </a:effectRef>
+          <a:fontRef idx="minor">
+            <a:schemeClr val="lt1"/>
+          </a:fontRef>
+        </p:style>
+        <p:txBody>
+          <a:bodyPr rtlCol="0" anchor="ctr"/>
+          <a:lstStyle/>
+          <a:p>
+            <a:pPr algn="ctr"/>
+          </a:p>
+        </p:txBody>
+      </p:sp>
+      <p:sp>
+        <p:nvSpPr>
+          <p:cNvPr id="39" name="TextBox 38"/>
+          <p:cNvSpPr txBox="1"/>
+          <p:nvPr/>
+        </p:nvSpPr>
+        <p:spPr>
+          <a:xfrm>
+            <a:off x="3666744" y="3547872"/>
+            <a:ext cx="2084831" cy="365760"/>
+          </a:xfrm>
+          <a:prstGeom prst="rect">
+            <a:avLst/>
+          </a:prstGeom>
+          <a:noFill/>
+        </p:spPr>
+        <p:txBody>
+          <a:bodyPr wrap="square" lIns="36576" rIns="36576" tIns="18288" bIns="18288" anchor="t">
+            <a:spAutoFit/>
+          </a:bodyPr>
+          <a:lstStyle/>
+          <a:p>
+            <a:pPr algn="ctr">
+              <a:lnSpc>
+                <a:spcPct val="100000"/>
+              </a:lnSpc>
+              <a:spcBef>
+                <a:spcPts val="0"/>
+              </a:spcBef>
+              <a:spcAft>
+                <a:spcPts val="0"/>
+              </a:spcAft>
+            </a:pPr>
+            <a:r>
+              <a:rPr sz="900" b="1">
+                <a:solidFill>
+                  <a:srgbClr val="548235"/>
+                </a:solidFill>
+                <a:latin typeface="Consolas"/>
+              </a:rPr>
+              <a:t>[B, T_local, H, D]</a:t>
+            </a:r>
+          </a:p>
+        </p:txBody>
+      </p:sp>
+      <p:sp>
+        <p:nvSpPr>
+          <p:cNvPr id="40" name="Left Arrow 39"/>
+          <p:cNvSpPr/>
+          <p:nvPr/>
+        </p:nvSpPr>
+        <p:spPr>
+          <a:xfrm>
+            <a:off x="2231136" y="4315968"/>
+            <a:ext cx="475488" cy="256032"/>
+          </a:xfrm>
+          <a:prstGeom prst="leftArrow">
+            <a:avLst/>
+          </a:prstGeom>
+          <a:solidFill>
+            <a:srgbClr val="548235"/>
+          </a:solidFill>
+          <a:ln>
+            <a:solidFill>
+              <a:srgbClr val="548235"/>
+            </a:solidFill>
+          </a:ln>
+        </p:spPr>
+        <p:style>
+          <a:lnRef idx="1">
+            <a:schemeClr val="accent1"/>
+          </a:lnRef>
+          <a:fillRef idx="3">
+            <a:schemeClr val="accent1"/>
+          </a:fillRef>
+          <a:effectRef idx="2">
+            <a:schemeClr val="accent1"/>
+          </a:effectRef>
+          <a:fontRef idx="minor">
+            <a:schemeClr val="lt1"/>
+          </a:fontRef>
+        </p:style>
+        <p:txBody>
+          <a:bodyPr rtlCol="0" anchor="ctr"/>
+          <a:lstStyle/>
+          <a:p>
+            <a:pPr algn="ctr"/>
+          </a:p>
+        </p:txBody>
+      </p:sp>
+      <p:sp>
+        <p:nvSpPr>
+          <p:cNvPr id="41" name="TextBox 40"/>
+          <p:cNvSpPr txBox="1"/>
+          <p:nvPr/>
+        </p:nvSpPr>
+        <p:spPr>
+          <a:xfrm>
+            <a:off x="1426464" y="3547872"/>
+            <a:ext cx="2084831" cy="365760"/>
+          </a:xfrm>
+          <a:prstGeom prst="rect">
+            <a:avLst/>
+          </a:prstGeom>
+          <a:noFill/>
+        </p:spPr>
+        <p:txBody>
+          <a:bodyPr wrap="square" lIns="36576" rIns="36576" tIns="18288" bIns="18288" anchor="t">
+            <a:spAutoFit/>
+          </a:bodyPr>
+          <a:lstStyle/>
+          <a:p>
+            <a:pPr algn="ctr">
+              <a:lnSpc>
+                <a:spcPct val="100000"/>
+              </a:lnSpc>
+              <a:spcBef>
+                <a:spcPts val="0"/>
+              </a:spcBef>
+              <a:spcAft>
+                <a:spcPts val="0"/>
+              </a:spcAft>
+            </a:pPr>
+            <a:r>
+              <a:rPr sz="900" b="1">
+                <a:solidFill>
+                  <a:srgbClr val="548235"/>
+                </a:solidFill>
+                <a:latin typeface="Consolas"/>
+              </a:rPr>
+              <a:t>[T_local, hidden]</a:t>
+            </a:r>
+          </a:p>
+        </p:txBody>
+      </p:sp>
+      <p:sp>
+        <p:nvSpPr>
+          <p:cNvPr id="42" name="TextBox 41"/>
+          <p:cNvSpPr txBox="1"/>
+          <p:nvPr/>
+        </p:nvSpPr>
+        <p:spPr>
+          <a:xfrm>
+            <a:off x="685800" y="5650992"/>
+            <a:ext cx="10835640" cy="292608"/>
+          </a:xfrm>
+          <a:prstGeom prst="rect">
+            <a:avLst/>
+          </a:prstGeom>
+          <a:noFill/>
+        </p:spPr>
+        <p:txBody>
+          <a:bodyPr wrap="square" lIns="36576" rIns="36576" tIns="18288" bIns="18288" anchor="t">
+            <a:spAutoFit/>
+          </a:bodyPr>
+          <a:lstStyle/>
+          <a:p>
+            <a:pPr algn="ctr">
+              <a:lnSpc>
+                <a:spcPct val="100000"/>
+              </a:lnSpc>
+              <a:spcBef>
+                <a:spcPts val="0"/>
+              </a:spcBef>
+              <a:spcAft>
+                <a:spcPts val="0"/>
+              </a:spcAft>
+            </a:pPr>
+            <a:r>
+              <a:rPr sz="1100" b="0">
+                <a:solidFill>
+                  <a:srgbClr val="666666"/>
+                </a:solidFill>
+                <a:latin typeface="Consolas"/>
+              </a:rPr>
+              <a:t>P=8 · T_local=4,720 · T_global=37,760 · H=56 · H/P=7 · D=128 · B=1</a:t>
+            </a:r>
+          </a:p>
+        </p:txBody>
+      </p:sp>
+      <p:cxnSp>
+        <p:nvCxnSpPr>
+          <p:cNvPr id="43" name="Connector 42"/>
+          <p:cNvCxnSpPr/>
+          <p:nvPr/>
+        </p:nvCxnSpPr>
+        <p:spPr>
+          <a:xfrm>
+            <a:off x="612648" y="6446520"/>
+            <a:ext cx="10954512" cy="0"/>
+          </a:xfrm>
+          <a:prstGeom prst="line">
+            <a:avLst/>
+          </a:prstGeom>
+          <a:ln w="8890">
+            <a:solidFill>
+              <a:srgbClr val="D9D9D9"/>
+            </a:solidFill>
+          </a:ln>
+        </p:spPr>
+        <p:style>
+          <a:lnRef idx="2">
+            <a:schemeClr val="accent1"/>
+          </a:lnRef>
+          <a:fillRef idx="0">
+            <a:schemeClr val="accent1"/>
+          </a:fillRef>
+          <a:effectRef idx="1">
+            <a:schemeClr val="accent1"/>
+          </a:effectRef>
+          <a:fontRef idx="minor">
+            <a:schemeClr val="tx1"/>
+          </a:fontRef>
+        </p:style>
+      </p:cxnSp>
+      <p:sp>
+        <p:nvSpPr>
+          <p:cNvPr id="44" name="TextBox 43"/>
+          <p:cNvSpPr txBox="1"/>
+          <p:nvPr/>
+        </p:nvSpPr>
+        <p:spPr>
+          <a:xfrm>
+            <a:off x="640080" y="6492240"/>
+            <a:ext cx="9875520" cy="164592"/>
+          </a:xfrm>
+          <a:prstGeom prst="rect">
+            <a:avLst/>
+          </a:prstGeom>
+          <a:noFill/>
+        </p:spPr>
+        <p:txBody>
+          <a:bodyPr wrap="square" lIns="36576" rIns="36576" tIns="18288" bIns="18288" anchor="t">
+            <a:spAutoFit/>
+          </a:bodyPr>
+          <a:lstStyle/>
+          <a:p>
+            <a:pPr algn="l">
+              <a:lnSpc>
+                <a:spcPct val="100000"/>
+              </a:lnSpc>
+              <a:spcBef>
+                <a:spcPts val="0"/>
+              </a:spcBef>
+              <a:spcAft>
+                <a:spcPts val="0"/>
+              </a:spcAft>
+            </a:pPr>
+            <a:r>
+              <a:rPr sz="800" b="0">
+                <a:solidFill>
+                  <a:srgbClr val="666666"/>
+                </a:solidFill>
+                <a:latin typeface="Consolas"/>
+              </a:rPr>
+              <a:t>Original profile: agent/minimax-h3-pillar1@50cf90da7</a:t>
+            </a:r>
+          </a:p>
+        </p:txBody>
+      </p:sp>
+      <p:sp>
+        <p:nvSpPr>
+          <p:cNvPr id="45" name="TextBox 44"/>
+          <p:cNvSpPr txBox="1"/>
+          <p:nvPr/>
+        </p:nvSpPr>
+        <p:spPr>
+          <a:xfrm>
+            <a:off x="10972800" y="6483096"/>
+            <a:ext cx="548640" cy="164592"/>
+          </a:xfrm>
+          <a:prstGeom prst="rect">
+            <a:avLst/>
+          </a:prstGeom>
+          <a:noFill/>
+        </p:spPr>
+        <p:txBody>
+          <a:bodyPr wrap="square" lIns="36576" rIns="36576" tIns="18288" bIns="18288" anchor="t">
+            <a:spAutoFit/>
+          </a:bodyPr>
+          <a:lstStyle/>
+          <a:p>
+            <a:pPr algn="r">
+              <a:lnSpc>
+                <a:spcPct val="100000"/>
+              </a:lnSpc>
+              <a:spcBef>
+                <a:spcPts val="0"/>
+              </a:spcBef>
+              <a:spcAft>
+                <a:spcPts val="0"/>
+              </a:spcAft>
+            </a:pPr>
+            <a:r>
+              <a:rPr sz="800" b="0">
+                <a:solidFill>
+                  <a:srgbClr val="666666"/>
+                </a:solidFill>
+                <a:latin typeface="Aptos"/>
+              </a:rPr>
+              <a:t>3</a:t>
+            </a:r>
+          </a:p>
+        </p:txBody>
+      </p:sp>
+    </p:spTree>
+  </p:cSld>
+  <p:clrMapOvr>
+    <a:masterClrMapping/>
+  </p:clrMapOvr>
+</p:sld>
+</file>
+
+<file path=ppt/slides/slide4.xml><?xml version="1.0" encoding="utf-8"?>
+<p:sld xmlns:a="http://schemas.openxmlformats.org/drawingml/2006/main" xmlns:p="http://schemas.openxmlformats.org/presentationml/2006/main" xmlns:r="http://schemas.openxmlformats.org/officeDocument/2006/relationships">
+  <p:cSld>
+    <p:spTree>
+      <p:nvGrpSpPr>
+        <p:cNvPr id="1" name=""/>
+        <p:cNvGrpSpPr/>
+        <p:nvPr/>
+      </p:nvGrpSpPr>
+      <p:grpSpPr/>
+      <p:sp>
+        <p:nvSpPr>
+          <p:cNvPr id="2" name="Title 1"/>
+          <p:cNvSpPr>
+            <a:spLocks noGrp="1"/>
+          </p:cNvSpPr>
+          <p:nvPr>
+            <p:ph type="title"/>
+          </p:nvPr>
+        </p:nvSpPr>
+        <p:spPr>
+          <a:xfrm>
+            <a:off x="594360" y="256032"/>
+            <a:ext cx="10972800" cy="502920"/>
+          </a:xfrm>
+        </p:spPr>
+        <p:txBody>
+          <a:bodyPr/>
+          <a:lstStyle/>
+          <a:p>
+            <a:r>
+              <a:rPr sz="2600" b="1">
+                <a:solidFill>
+                  <a:srgbClr val="1F1F1F"/>
+                </a:solidFill>
+                <a:latin typeface="Aptos"/>
+              </a:rPr>
               <a:t>Bottleneck</a:t>
             </a:r>
           </a:p>
@@ -5927,7 +8062,7 @@
                 </a:solidFill>
                 <a:latin typeface="Aptos"/>
               </a:rPr>
-              <a:t>3</a:t>
+              <a:t>4</a:t>
             </a:r>
           </a:p>
         </p:txBody>
@@ -5940,7 +8075,7 @@
 </p:sld>
 </file>
 
-<file path=ppt/slides/slide4.xml><?xml version="1.0" encoding="utf-8"?>
+<file path=ppt/slides/slide5.xml><?xml version="1.0" encoding="utf-8"?>
 <p:sld xmlns:a="http://schemas.openxmlformats.org/drawingml/2006/main" xmlns:p="http://schemas.openxmlformats.org/presentationml/2006/main" xmlns:r="http://schemas.openxmlformats.org/officeDocument/2006/relationships">
   <p:cSld>
     <p:spTree>
@@ -6661,7 +8796,7 @@
                 </a:solidFill>
                 <a:latin typeface="Aptos"/>
               </a:rPr>
-              <a:t>4</a:t>
+              <a:t>5</a:t>
             </a:r>
           </a:p>
         </p:txBody>
@@ -6674,7 +8809,7 @@
 </p:sld>
 </file>
 
-<file path=ppt/slides/slide5.xml><?xml version="1.0" encoding="utf-8"?>
+<file path=ppt/slides/slide6.xml><?xml version="1.0" encoding="utf-8"?>
 <p:sld xmlns:a="http://schemas.openxmlformats.org/drawingml/2006/main" xmlns:p="http://schemas.openxmlformats.org/presentationml/2006/main" xmlns:r="http://schemas.openxmlformats.org/officeDocument/2006/relationships">
   <p:cSld>
     <p:spTree>
@@ -7476,7 +9611,7 @@
                 </a:solidFill>
                 <a:latin typeface="Aptos"/>
               </a:rPr>
-              <a:t>5</a:t>
+              <a:t>6</a:t>
             </a:r>
           </a:p>
         </p:txBody>
@@ -7489,7 +9624,7 @@
 </p:sld>
 </file>
 
-<file path=ppt/slides/slide6.xml><?xml version="1.0" encoding="utf-8"?>
+<file path=ppt/slides/slide7.xml><?xml version="1.0" encoding="utf-8"?>
 <p:sld xmlns:a="http://schemas.openxmlformats.org/drawingml/2006/main" xmlns:p="http://schemas.openxmlformats.org/presentationml/2006/main" xmlns:r="http://schemas.openxmlformats.org/officeDocument/2006/relationships">
   <p:cSld>
     <p:spTree>
@@ -8197,7 +10332,7 @@
                 </a:solidFill>
                 <a:latin typeface="Aptos"/>
               </a:rPr>
-              <a:t>6</a:t>
+              <a:t>7</a:t>
             </a:r>
           </a:p>
         </p:txBody>

</xml_diff>